<commit_message>
Update youtube book tie-in references from Chapter 12 to Chapter 11
The book dropped its codebase chapter and renumbered 12->11, so the
OpenRouter material now lands in Chapter 11. Updated the script, outline,
description, and slide 23 of the deck (text and speaker notes; slide
visually verified via LibreOffice render).

Co-Authored-By: Claude Fable 5 <noreply@anthropic.com>
</commit_message>
<xml_diff>
--- a/youtube/Claude_Code_with_OpenRouter.pptx
+++ b/youtube/Claude_Code_with_OpenRouter.pptx
@@ -1845,7 +1845,7 @@
           <a:p>
             <a:r>
               <a:rPr lang="en-US" dirty="0"/>
-              <a:t>This ties into my book, Claude Code: Up and Running, from O'Reilly. The OpenRouter material lands in Chapter 12, coming to the early release a bit later. The orclaude script is in the book's example repo.</a:t>
+              <a:t>This ties into my book, Claude Code: Up and Running, from O'Reilly. The OpenRouter material lands in Chapter 11, coming to the early release a bit later. The orclaude script is in the book's example repo.</a:t>
             </a:r>
             <a:endParaRPr lang="en-US" dirty="0"/>
           </a:p>
@@ -13282,7 +13282,7 @@
                 <a:ea typeface="Arial" pitchFamily="34" charset="-122"/>
                 <a:cs typeface="Arial" pitchFamily="34" charset="-120"/>
               </a:rPr>
-              <a:t xml:space="preserve">Chapter 12 </a:t>
+              <a:t xml:space="preserve">Chapter 11 </a:t>
             </a:r>
             <a:pPr algn="l" indent="0" marL="0">
               <a:lnSpc>

</xml_diff>